<commit_message>
fix: resolve all type and linter issues across codebase
</commit_message>
<xml_diff>
--- a/Hackfest_2026_Screening_Presentation.pptx
+++ b/Hackfest_2026_Screening_Presentation.pptx
@@ -3949,7 +3949,7 @@
                   <a:srgbClr val="0F172A"/>
                 </a:solidFill>
               </a:rPr>
-              <a:t>Diabetic inpatients face extreme vulnerability: 43.8% suffer from polypharmacy (&gt;=10 active medications), compounding metabolic and cardiovascular relapse risk.</a:t>
+              <a:t>Diabetic inpatients face extreme vulnerability: 79.0% have &gt;=10 distinct medications administered during their stay, compounding metabolic and cardiovascular relapse risk.</a:t>
             </a:r>
           </a:p>
           <a:p>
@@ -4285,7 +4285,7 @@
               </a:defRPr>
             </a:pPr>
             <a:r>
-              <a:t>43.80%</a:t>
+              <a:t>79.00%</a:t>
             </a:r>
           </a:p>
           <a:p>
@@ -4300,7 +4300,7 @@
               </a:defRPr>
             </a:pPr>
             <a:r>
-              <a:t>Polypharmacy Alert Rate</a:t>
+              <a:t>High Medication Intensity</a:t>
             </a:r>
           </a:p>
           <a:p>
@@ -4315,7 +4315,7 @@
               </a:defRPr>
             </a:pPr>
             <a:r>
-              <a:t>Inpatients taking &gt;=10 active medications facing severe adverse drug interactions.</a:t>
+              <a:t>Inpatients receiving &gt;=10 distinct medications during stay (79% of sample).</a:t>
             </a:r>
           </a:p>
         </p:txBody>

</xml_diff>